<commit_message>
docs: link live deployed Netlify website across README, demo script, PDF, and pitch deck
</commit_message>
<xml_diff>
--- a/StellarRise_Pitch_Deck.pptx
+++ b/StellarRise_Pitch_Deck.pptx
@@ -3189,12 +3189,12 @@
               </a:spcBef>
               <a:defRPr sz="1600">
                 <a:solidFill>
-                  <a:srgbClr val="94A3B8"/>
+                  <a:srgbClr val="38BDF8"/>
                 </a:solidFill>
               </a:defRPr>
             </a:pPr>
             <a:r>
-              <a:t>Production-Grade Zero-Knowledge DAO Voting with Publicly Verifiable Tallies | RiseIn Moonshots</a:t>
+              <a:t>Live DApp: https://privacypreservingmidnightmoonlight.netlify.app | RiseIn Moonshots</a:t>
             </a:r>
           </a:p>
         </p:txBody>

</xml_diff>